<commit_message>
seo and sitemap changes
</commit_message>
<xml_diff>
--- a/FixGrid_Innovation_Presentation.pptx
+++ b/FixGrid_Innovation_Presentation.pptx
@@ -509,7 +509,7 @@
           <a:p>
             <a:r>
               <a:rPr lang="en-US" dirty="0"/>
-              <a:t>Welcome. FixGrid unites a live web marketplace with a low-cost physical diagnostic wand, solving both the digital trust void and the technical hardware diagnostic barrier.</a:t>
+              <a:t>Welcome. FixGrid Probe unites a live web marketplace with a low-cost physical diagnostic wand, solving both the digital trust void and the technical hardware diagnostic barrier.</a:t>
             </a:r>
             <a:endParaRPr lang="en-US" dirty="0"/>
           </a:p>
@@ -685,7 +685,7 @@
           <a:p>
             <a:r>
               <a:rPr lang="en-US" dirty="0"/>
-              <a:t>From the synopsis: SafeProbe merges physics and digital governance. It tests in-circuit at 0.40V without desoldering, snaps macro photos of 0402 SMDs, links to a Dual-Loop QR warranty seal, and acts as a hardware trust-gate releasing escrow.</a:t>
+              <a:t>From the synopsis: FixGrid Probe merges physics and digital governance. It tests in-circuit at 0.40V without desoldering, snaps macro photos of 0402 SMDs, links to a Dual-Loop QR warranty seal, and acts as a hardware trust-gate releasing escrow.</a:t>
             </a:r>
             <a:endParaRPr lang="en-US" dirty="0"/>
           </a:p>
@@ -773,7 +773,7 @@
           <a:p>
             <a:r>
               <a:rPr lang="en-US" dirty="0"/>
-              <a:t>SafeProbe provides three capabilities in one wand: micro-touch fault sensing with instant beeps, macro photo proof sent to the phone, and a tamper-evident digital warranty seal.</a:t>
+              <a:t>FixGrid Probe provides three capabilities in one wand: micro-touch fault sensing with instant beeps, macro photo proof sent to the phone, and a tamper-evident digital warranty seal.</a:t>
             </a:r>
             <a:endParaRPr lang="en-US" dirty="0"/>
           </a:p>
@@ -949,7 +949,7 @@
           <a:p>
             <a:r>
               <a:rPr lang="en-US" dirty="0"/>
-              <a:t>This is where the magic happens: the SafeProbe hardware records the repair, generates a tamper-evident holographic QR seal, and the customer scans it on their phone to see verified before-and-after photos and activate their warranty.</a:t>
+              <a:t>This is where the magic happens: the FixGrid Probe hardware records the repair, generates a tamper-evident holographic QR seal, and the customer scans it on their phone to see verified before-and-after photos and activate their warranty.</a:t>
             </a:r>
             <a:endParaRPr lang="en-US" dirty="0"/>
           </a:p>
@@ -1125,7 +1125,7 @@
           <a:p>
             <a:r>
               <a:rPr lang="en-US" dirty="0"/>
-              <a:t>Thank you. FixGrid and SafeProbe demonstrate that with frugal engineering and digital trust, we can empower local artisans, save consumers money, and protect our environment from toxic e-waste.</a:t>
+              <a:t>Thank you. FixGrid and FixGrid Probe demonstrate that with frugal engineering and digital trust, we can empower local artisans, save consumers money, and protect our environment from toxic e-waste.</a:t>
             </a:r>
             <a:endParaRPr lang="en-US" dirty="0"/>
           </a:p>
@@ -1597,7 +1597,7 @@
                 <a:ea typeface="Cambria" pitchFamily="34" charset="-122"/>
                 <a:cs typeface="Cambria" pitchFamily="34" charset="-120"/>
               </a:rPr>
-              <a:t>FixGrid &amp; SafeProbe™</a:t>
+              <a:t>FixGrid Probe™</a:t>
             </a:r>
             <a:endParaRPr lang="en-US" sz="3800" dirty="0"/>
           </a:p>
@@ -1771,7 +1771,7 @@
                 <a:ea typeface="Calibri" pitchFamily="34" charset="-122"/>
                 <a:cs typeface="Calibri" pitchFamily="34" charset="-120"/>
               </a:rPr>
-              <a:t>✓  Physical Innovation: Under ₹1,800 SafeProbe™ sub-junction diagnostic wand</a:t>
+              <a:t>✓  Physical Innovation: Under ₹1,800 FixGrid Probe™ sub-junction diagnostic wand</a:t>
             </a:r>
             <a:endParaRPr lang="en-US" sz="950" dirty="0"/>
           </a:p>
@@ -2013,8 +2013,8 @@
         </p:nvSpPr>
         <p:spPr>
           <a:xfrm>
-            <a:off x="5257800" y="4005072"/>
-            <a:ext cx="2286000" cy="201168"/>
+            <a:off x="5166360" y="4005072"/>
+            <a:ext cx="2468880" cy="201168"/>
           </a:xfrm>
           <a:prstGeom prst="roundRect">
             <a:avLst>
@@ -2040,8 +2040,8 @@
         </p:nvSpPr>
         <p:spPr>
           <a:xfrm>
-            <a:off x="5257800" y="4005072"/>
-            <a:ext cx="2286000" cy="201168"/>
+            <a:off x="5166360" y="4005072"/>
+            <a:ext cx="2468880" cy="201168"/>
           </a:xfrm>
           <a:prstGeom prst="rect">
             <a:avLst/>
@@ -2065,7 +2065,7 @@
                 <a:ea typeface="Calibri" pitchFamily="34" charset="-122"/>
                 <a:cs typeface="Calibri" pitchFamily="34" charset="-120"/>
               </a:rPr>
-              <a:t>SafeProbe™ Working Prototype</a:t>
+              <a:t>FixGrid Probe™ Working Prototype</a:t>
             </a:r>
             <a:endParaRPr lang="en-US" sz="800" dirty="0"/>
           </a:p>
@@ -2182,7 +2182,7 @@
                 <a:ea typeface="Calibri" pitchFamily="34" charset="-122"/>
                 <a:cs typeface="Calibri" pitchFamily="34" charset="-120"/>
               </a:rPr>
-              <a:t>Live Web Platform  +  SafeProbe™ Frugal Diagnostics</a:t>
+              <a:t>Live Web Platform  +  FixGrid Probe™ Diagnostics</a:t>
             </a:r>
             <a:endParaRPr lang="en-US" sz="850" dirty="0"/>
           </a:p>
@@ -3275,7 +3275,7 @@
                 <a:ea typeface="Calibri" pitchFamily="34" charset="-122"/>
                 <a:cs typeface="Calibri" pitchFamily="34" charset="-120"/>
               </a:rPr>
-              <a:t>Live Web Platform  +  SafeProbe™ Frugal Diagnostics</a:t>
+              <a:t>Live Web Platform  +  FixGrid Probe™ Diagnostics</a:t>
             </a:r>
             <a:endParaRPr lang="en-US" sz="850" dirty="0"/>
           </a:p>
@@ -3872,7 +3872,7 @@
                 <a:ea typeface="Calibri" pitchFamily="34" charset="-122"/>
                 <a:cs typeface="Calibri" pitchFamily="34" charset="-120"/>
               </a:rPr>
-              <a:t>SafeProbe™ Multimodal Diagnostic Tool</a:t>
+              <a:t>FixGrid Probe™ Multimodal Diagnostic Tool</a:t>
             </a:r>
             <a:endParaRPr lang="en-US" sz="1250" dirty="0"/>
           </a:p>
@@ -4527,7 +4527,7 @@
                 <a:ea typeface="Calibri" pitchFamily="34" charset="-122"/>
                 <a:cs typeface="Calibri" pitchFamily="34" charset="-120"/>
               </a:rPr>
-              <a:t>Live Web Platform  +  SafeProbe™ Frugal Diagnostics</a:t>
+              <a:t>Live Web Platform  +  FixGrid Probe™ Diagnostics</a:t>
             </a:r>
             <a:endParaRPr lang="en-US" sz="850" dirty="0"/>
           </a:p>
@@ -4742,7 +4742,7 @@
                 <a:ea typeface="Cambria" pitchFamily="34" charset="-122"/>
                 <a:cs typeface="Cambria" pitchFamily="34" charset="-120"/>
               </a:rPr>
-              <a:t>SafeProbe™: Lab Diagnostics in a Handheld Wand</a:t>
+              <a:t>FixGrid Probe™: Lab Diagnostics in a Handheld Wand</a:t>
             </a:r>
             <a:endParaRPr lang="en-US" sz="2200" dirty="0"/>
           </a:p>
@@ -4856,7 +4856,7 @@
                 <a:ea typeface="Calibri" pitchFamily="34" charset="-122"/>
                 <a:cs typeface="Calibri" pitchFamily="34" charset="-120"/>
               </a:rPr>
-              <a:t>SafeProbe™ Working Prototype (₹1,795 / ~$21 BOM)</a:t>
+              <a:t>FixGrid Probe™ Working Prototype (₹1,795 / ~$21 BOM)</a:t>
             </a:r>
             <a:endParaRPr lang="en-US" sz="850" dirty="0"/>
           </a:p>
@@ -5495,7 +5495,7 @@
                 <a:ea typeface="Calibri" pitchFamily="34" charset="-122"/>
                 <a:cs typeface="Calibri" pitchFamily="34" charset="-120"/>
               </a:rPr>
-              <a:t>Live Web Platform  +  SafeProbe™ Frugal Diagnostics</a:t>
+              <a:t>Live Web Platform  +  FixGrid Probe™ Diagnostics</a:t>
             </a:r>
             <a:endParaRPr lang="en-US" sz="850" dirty="0"/>
           </a:p>
@@ -6382,7 +6382,7 @@
                 <a:ea typeface="Calibri" pitchFamily="34" charset="-122"/>
                 <a:cs typeface="Calibri" pitchFamily="34" charset="-120"/>
               </a:rPr>
-              <a:t>Live Web Platform  +  SafeProbe™ Frugal Diagnostics</a:t>
+              <a:t>Live Web Platform  +  FixGrid Probe™ Diagnostics</a:t>
             </a:r>
             <a:endParaRPr lang="en-US" sz="850" dirty="0"/>
           </a:p>
@@ -6816,7 +6816,7 @@
                 <a:ea typeface="Calibri" pitchFamily="34" charset="-122"/>
                 <a:cs typeface="Calibri" pitchFamily="34" charset="-120"/>
               </a:rPr>
-              <a:t>SafeProbe Diagnostics Upload</a:t>
+              <a:t>FixGrid Probe Diagnostics Upload</a:t>
             </a:r>
             <a:endParaRPr lang="en-US" sz="1150" dirty="0"/>
           </a:p>
@@ -6858,7 +6858,7 @@
                 <a:ea typeface="Calibri" pitchFamily="34" charset="-122"/>
                 <a:cs typeface="Calibri" pitchFamily="34" charset="-120"/>
               </a:rPr>
-              <a:t>When the technician completes the repair across any category, the SafeProbe wand syncs the passing impedance test and high-res macro photos directly to the FixGrid cloud database via ESP32 Wi-Fi/BLE.</a:t>
+              <a:t>When the technician completes the repair across any category, the FixGrid Probe wand syncs the passing impedance test and high-res macro photos directly to the FixGrid cloud database via ESP32 Wi-Fi/BLE.</a:t>
             </a:r>
             <a:endParaRPr lang="en-US" sz="850" dirty="0"/>
           </a:p>
@@ -7269,7 +7269,7 @@
                 <a:ea typeface="Calibri" pitchFamily="34" charset="-122"/>
                 <a:cs typeface="Calibri" pitchFamily="34" charset="-120"/>
               </a:rPr>
-              <a:t>Live Web Platform  +  SafeProbe™ Frugal Diagnostics</a:t>
+              <a:t>Live Web Platform  +  FixGrid Probe™ Diagnostics</a:t>
             </a:r>
             <a:endParaRPr lang="en-US" sz="850" dirty="0"/>
           </a:p>
@@ -8135,7 +8135,7 @@
                 <a:ea typeface="Calibri" pitchFamily="34" charset="-122"/>
                 <a:cs typeface="Calibri" pitchFamily="34" charset="-120"/>
               </a:rPr>
-              <a:t>Household repair pass: free SafeProbe diagnostics, zero booking fees &amp; 60-day warranty.</a:t>
+              <a:t>Household repair pass: free FixGrid Probe diagnostics, zero booking fees &amp; 60-day warranty.</a:t>
             </a:r>
             <a:endParaRPr lang="en-US" sz="850" dirty="0"/>
           </a:p>
@@ -8240,7 +8240,7 @@
                 <a:ea typeface="Calibri" pitchFamily="34" charset="-122"/>
                 <a:cs typeface="Calibri" pitchFamily="34" charset="-120"/>
               </a:rPr>
-              <a:t>SafeProbe firmware updates, warranty management, digital store CRM &amp; analytics.</a:t>
+              <a:t>FixGrid Probe firmware updates, warranty management, digital store CRM &amp; analytics.</a:t>
             </a:r>
             <a:endParaRPr lang="en-US" sz="850" dirty="0"/>
           </a:p>
@@ -8462,7 +8462,7 @@
                 <a:ea typeface="Calibri" pitchFamily="34" charset="-122"/>
                 <a:cs typeface="Calibri" pitchFamily="34" charset="-120"/>
               </a:rPr>
-              <a:t>Live Web Platform  +  SafeProbe™ Frugal Diagnostics</a:t>
+              <a:t>Live Web Platform  +  FixGrid Probe™ Diagnostics</a:t>
             </a:r>
             <a:endParaRPr lang="en-US" sz="850" dirty="0"/>
           </a:p>
@@ -8867,7 +8867,7 @@
                 <a:ea typeface="Calibri" pitchFamily="34" charset="-122"/>
                 <a:cs typeface="Calibri" pitchFamily="34" charset="-120"/>
               </a:rPr>
-              <a:t>Deploy 50 SafeProbe units across Mumbai electronics repair markets.</a:t>
+              <a:t>Deploy 50 FixGrid Probe units across Mumbai electronics repair markets.</a:t>
             </a:r>
             <a:endParaRPr lang="en-US" sz="950" dirty="0"/>
           </a:p>
@@ -9319,7 +9319,7 @@
                 <a:ea typeface="Calibri" pitchFamily="34" charset="-122"/>
                 <a:cs typeface="Calibri" pitchFamily="34" charset="-120"/>
               </a:rPr>
-              <a:t>Scale frugal SafeProbe tool manufacturing to local repairers nationwide.</a:t>
+              <a:t>Scale frugal FixGrid Probe tool manufacturing to local repairers nationwide.</a:t>
             </a:r>
             <a:endParaRPr lang="en-US" sz="950" dirty="0"/>
           </a:p>
@@ -9385,7 +9385,7 @@
                 <a:ea typeface="Calibri" pitchFamily="34" charset="-122"/>
                 <a:cs typeface="Calibri" pitchFamily="34" charset="-120"/>
               </a:rPr>
-              <a:t>FixGrid &amp; SafeProbe™ Ecosystem</a:t>
+              <a:t>FixGrid Probe™ Unified Ecosystem</a:t>
             </a:r>
             <a:endParaRPr lang="en-US" sz="1300" dirty="0"/>
           </a:p>
@@ -9619,7 +9619,7 @@
                 <a:ea typeface="Calibri" pitchFamily="34" charset="-122"/>
                 <a:cs typeface="Calibri" pitchFamily="34" charset="-120"/>
               </a:rPr>
-              <a:t>Live Web Platform  +  SafeProbe™ Frugal Diagnostics</a:t>
+              <a:t>Live Web Platform  +  FixGrid Probe™ Diagnostics</a:t>
             </a:r>
             <a:endParaRPr lang="en-US" sz="850" dirty="0"/>
           </a:p>

</xml_diff>